<commit_message>
Add more porting advise
</commit_message>
<xml_diff>
--- a/python_on_gpus.pptx
+++ b/python_on_gpus.pptx
@@ -23737,6 +23737,28 @@
               <a:rPr lang="en-US" dirty="0"/>
               <a:t> exploit mixed precision</a:t>
             </a:r>
+          </a:p>
+          <a:p>
+            <a:r>
+              <a:rPr lang="en-US" dirty="0"/>
+              <a:t>More instruction level parallelism </a:t>
+            </a:r>
+            <a:r>
+              <a:rPr lang="en-US" dirty="0">
+                <a:sym typeface="Symbol" panose="05050102010706020507" pitchFamily="18" charset="2"/>
+              </a:rPr>
+              <a:t></a:t>
+            </a:r>
+            <a:r>
+              <a:rPr lang="en-US" dirty="0"/>
+              <a:t> occupancy can decrease</a:t>
+            </a:r>
+          </a:p>
+          <a:p>
+            <a:r>
+              <a:rPr lang="en-US" dirty="0"/>
+              <a:t>Overlap memory transfer and computation</a:t>
+            </a:r>
             <a:endParaRPr lang="LID4096" dirty="0"/>
           </a:p>
         </p:txBody>
@@ -23767,6 +23789,47 @@
               <a:t>32</a:t>
             </a:fld>
             <a:endParaRPr lang="LID4096"/>
+          </a:p>
+        </p:txBody>
+      </p:sp>
+      <p:sp>
+        <p:nvSpPr>
+          <p:cNvPr id="5" name="TextBox 4">
+            <a:extLst>
+              <a:ext uri="{FF2B5EF4-FFF2-40B4-BE49-F238E27FC236}">
+                <a16:creationId xmlns:a16="http://schemas.microsoft.com/office/drawing/2014/main" id="{E9EF0402-951C-D71C-B422-165CE2CF2B87}"/>
+              </a:ext>
+            </a:extLst>
+          </p:cNvPr>
+          <p:cNvSpPr txBox="1"/>
+          <p:nvPr/>
+        </p:nvSpPr>
+        <p:spPr>
+          <a:xfrm>
+            <a:off x="4348976" y="4928839"/>
+            <a:ext cx="2069797" cy="830997"/>
+          </a:xfrm>
+          <a:prstGeom prst="rect">
+            <a:avLst/>
+          </a:prstGeom>
+          <a:noFill/>
+          <a:ln>
+            <a:solidFill>
+              <a:schemeClr val="tx1"/>
+            </a:solidFill>
+          </a:ln>
+        </p:spPr>
+        <p:txBody>
+          <a:bodyPr wrap="none" rtlCol="0">
+            <a:spAutoFit/>
+          </a:bodyPr>
+          <a:lstStyle/>
+          <a:p>
+            <a:r>
+              <a:rPr lang="en-US" sz="4800" dirty="0"/>
+              <a:t>Profile!</a:t>
+            </a:r>
+            <a:endParaRPr lang="LID4096" sz="4800" dirty="0"/>
           </a:p>
         </p:txBody>
       </p:sp>
@@ -23938,6 +24001,149 @@
                       </p:childTnLst>
                     </p:cTn>
                   </p:par>
+                  <p:par>
+                    <p:cTn id="15" fill="hold">
+                      <p:stCondLst>
+                        <p:cond delay="indefinite"/>
+                      </p:stCondLst>
+                      <p:childTnLst>
+                        <p:par>
+                          <p:cTn id="16" fill="hold">
+                            <p:stCondLst>
+                              <p:cond delay="0"/>
+                            </p:stCondLst>
+                            <p:childTnLst>
+                              <p:par>
+                                <p:cTn id="17" presetID="1" presetClass="entr" presetSubtype="0" fill="hold" grpId="0" nodeType="clickEffect">
+                                  <p:stCondLst>
+                                    <p:cond delay="0"/>
+                                  </p:stCondLst>
+                                  <p:childTnLst>
+                                    <p:set>
+                                      <p:cBhvr>
+                                        <p:cTn id="18" dur="1" fill="hold">
+                                          <p:stCondLst>
+                                            <p:cond delay="0"/>
+                                          </p:stCondLst>
+                                        </p:cTn>
+                                        <p:tgtEl>
+                                          <p:spTgt spid="3">
+                                            <p:txEl>
+                                              <p:pRg st="3" end="3"/>
+                                            </p:txEl>
+                                          </p:spTgt>
+                                        </p:tgtEl>
+                                        <p:attrNameLst>
+                                          <p:attrName>style.visibility</p:attrName>
+                                        </p:attrNameLst>
+                                      </p:cBhvr>
+                                      <p:to>
+                                        <p:strVal val="visible"/>
+                                      </p:to>
+                                    </p:set>
+                                  </p:childTnLst>
+                                </p:cTn>
+                              </p:par>
+                            </p:childTnLst>
+                          </p:cTn>
+                        </p:par>
+                      </p:childTnLst>
+                    </p:cTn>
+                  </p:par>
+                  <p:par>
+                    <p:cTn id="19" fill="hold">
+                      <p:stCondLst>
+                        <p:cond delay="indefinite"/>
+                      </p:stCondLst>
+                      <p:childTnLst>
+                        <p:par>
+                          <p:cTn id="20" fill="hold">
+                            <p:stCondLst>
+                              <p:cond delay="0"/>
+                            </p:stCondLst>
+                            <p:childTnLst>
+                              <p:par>
+                                <p:cTn id="21" presetID="1" presetClass="entr" presetSubtype="0" fill="hold" grpId="0" nodeType="clickEffect">
+                                  <p:stCondLst>
+                                    <p:cond delay="0"/>
+                                  </p:stCondLst>
+                                  <p:childTnLst>
+                                    <p:set>
+                                      <p:cBhvr>
+                                        <p:cTn id="22" dur="1" fill="hold">
+                                          <p:stCondLst>
+                                            <p:cond delay="0"/>
+                                          </p:stCondLst>
+                                        </p:cTn>
+                                        <p:tgtEl>
+                                          <p:spTgt spid="3">
+                                            <p:txEl>
+                                              <p:pRg st="4" end="4"/>
+                                            </p:txEl>
+                                          </p:spTgt>
+                                        </p:tgtEl>
+                                        <p:attrNameLst>
+                                          <p:attrName>style.visibility</p:attrName>
+                                        </p:attrNameLst>
+                                      </p:cBhvr>
+                                      <p:to>
+                                        <p:strVal val="visible"/>
+                                      </p:to>
+                                    </p:set>
+                                  </p:childTnLst>
+                                </p:cTn>
+                              </p:par>
+                            </p:childTnLst>
+                          </p:cTn>
+                        </p:par>
+                      </p:childTnLst>
+                    </p:cTn>
+                  </p:par>
+                  <p:par>
+                    <p:cTn id="23" fill="hold">
+                      <p:stCondLst>
+                        <p:cond delay="indefinite"/>
+                      </p:stCondLst>
+                      <p:childTnLst>
+                        <p:par>
+                          <p:cTn id="24" fill="hold">
+                            <p:stCondLst>
+                              <p:cond delay="0"/>
+                            </p:stCondLst>
+                            <p:childTnLst>
+                              <p:par>
+                                <p:cTn id="25" presetID="1" presetClass="entr" presetSubtype="0" fill="hold" grpId="0" nodeType="clickEffect">
+                                  <p:stCondLst>
+                                    <p:cond delay="0"/>
+                                  </p:stCondLst>
+                                  <p:childTnLst>
+                                    <p:set>
+                                      <p:cBhvr>
+                                        <p:cTn id="26" dur="1" fill="hold">
+                                          <p:stCondLst>
+                                            <p:cond delay="0"/>
+                                          </p:stCondLst>
+                                        </p:cTn>
+                                        <p:tgtEl>
+                                          <p:spTgt spid="5"/>
+                                        </p:tgtEl>
+                                        <p:attrNameLst>
+                                          <p:attrName>style.visibility</p:attrName>
+                                        </p:attrNameLst>
+                                      </p:cBhvr>
+                                      <p:to>
+                                        <p:strVal val="visible"/>
+                                      </p:to>
+                                    </p:set>
+                                  </p:childTnLst>
+                                </p:cTn>
+                              </p:par>
+                            </p:childTnLst>
+                          </p:cTn>
+                        </p:par>
+                      </p:childTnLst>
+                    </p:cTn>
+                  </p:par>
                 </p:childTnLst>
               </p:cTn>
               <p:prevCondLst>
@@ -23961,6 +24167,7 @@
     </p:tnLst>
     <p:bldLst>
       <p:bldP spid="3" grpId="0" uiExpand="1" build="p"/>
+      <p:bldP spid="5" grpId="0" animBg="1"/>
     </p:bldLst>
   </p:timing>
 </p:sld>

</xml_diff>

<commit_message>
Add slide on programming best practices
</commit_message>
<xml_diff>
--- a/python_on_gpus.pptx
+++ b/python_on_gpus.pptx
@@ -5,7 +5,7 @@
     <p:sldMasterId id="2147483648" r:id="rId1"/>
   </p:sldMasterIdLst>
   <p:notesMasterIdLst>
-    <p:notesMasterId r:id="rId34"/>
+    <p:notesMasterId r:id="rId35"/>
   </p:notesMasterIdLst>
   <p:sldIdLst>
     <p:sldId id="257" r:id="rId2"/>
@@ -34,12 +34,13 @@
     <p:sldId id="385" r:id="rId25"/>
     <p:sldId id="386" r:id="rId26"/>
     <p:sldId id="387" r:id="rId27"/>
-    <p:sldId id="373" r:id="rId28"/>
-    <p:sldId id="378" r:id="rId29"/>
-    <p:sldId id="367" r:id="rId30"/>
-    <p:sldId id="370" r:id="rId31"/>
-    <p:sldId id="377" r:id="rId32"/>
-    <p:sldId id="371" r:id="rId33"/>
+    <p:sldId id="388" r:id="rId28"/>
+    <p:sldId id="373" r:id="rId29"/>
+    <p:sldId id="378" r:id="rId30"/>
+    <p:sldId id="367" r:id="rId31"/>
+    <p:sldId id="370" r:id="rId32"/>
+    <p:sldId id="377" r:id="rId33"/>
+    <p:sldId id="371" r:id="rId34"/>
   </p:sldIdLst>
   <p:sldSz cx="12192000" cy="6858000"/>
   <p:notesSz cx="6858000" cy="9144000"/>
@@ -273,7 +274,7 @@
           <a:p>
             <a:fld id="{8BC644CB-8FFF-4F59-B04D-9A1D2A5DB720}" type="datetimeFigureOut">
               <a:rPr lang="LID4096" smtClean="0"/>
-              <a:t>03/10/2026</a:t>
+              <a:t>03/12/2026</a:t>
             </a:fld>
             <a:endParaRPr lang="LID4096"/>
           </a:p>
@@ -690,7 +691,7 @@
           <a:p>
             <a:fld id="{29DC7A01-813B-4B59-A1CC-F2D63921E46A}" type="datetime1">
               <a:rPr lang="LID4096" smtClean="0"/>
-              <a:t>03/10/2026</a:t>
+              <a:t>03/12/2026</a:t>
             </a:fld>
             <a:endParaRPr lang="LID4096"/>
           </a:p>
@@ -890,7 +891,7 @@
           <a:p>
             <a:fld id="{6C2A7740-B6F2-4CC5-9AD0-B161B943DB10}" type="datetime1">
               <a:rPr lang="LID4096" smtClean="0"/>
-              <a:t>03/10/2026</a:t>
+              <a:t>03/12/2026</a:t>
             </a:fld>
             <a:endParaRPr lang="LID4096"/>
           </a:p>
@@ -1100,7 +1101,7 @@
           <a:p>
             <a:fld id="{2F94B025-8F26-4EDF-B991-413B82D6446E}" type="datetime1">
               <a:rPr lang="LID4096" smtClean="0"/>
-              <a:t>03/10/2026</a:t>
+              <a:t>03/12/2026</a:t>
             </a:fld>
             <a:endParaRPr lang="LID4096"/>
           </a:p>
@@ -1300,7 +1301,7 @@
           <a:p>
             <a:fld id="{CB5C8B8A-B2CE-4D78-88A4-476B2363B71E}" type="datetime1">
               <a:rPr lang="LID4096" smtClean="0"/>
-              <a:t>03/10/2026</a:t>
+              <a:t>03/12/2026</a:t>
             </a:fld>
             <a:endParaRPr lang="LID4096"/>
           </a:p>
@@ -1576,7 +1577,7 @@
           <a:p>
             <a:fld id="{CDDAB553-EE67-480E-BCE3-F64D7D51D294}" type="datetime1">
               <a:rPr lang="LID4096" smtClean="0"/>
-              <a:t>03/10/2026</a:t>
+              <a:t>03/12/2026</a:t>
             </a:fld>
             <a:endParaRPr lang="LID4096"/>
           </a:p>
@@ -1844,7 +1845,7 @@
           <a:p>
             <a:fld id="{CD270038-A599-4345-BE24-96A4E06BF8E3}" type="datetime1">
               <a:rPr lang="LID4096" smtClean="0"/>
-              <a:t>03/10/2026</a:t>
+              <a:t>03/12/2026</a:t>
             </a:fld>
             <a:endParaRPr lang="LID4096"/>
           </a:p>
@@ -2259,7 +2260,7 @@
           <a:p>
             <a:fld id="{44A719F7-59BE-4FD1-8AC5-F7BFCCA290D7}" type="datetime1">
               <a:rPr lang="LID4096" smtClean="0"/>
-              <a:t>03/10/2026</a:t>
+              <a:t>03/12/2026</a:t>
             </a:fld>
             <a:endParaRPr lang="LID4096"/>
           </a:p>
@@ -2401,7 +2402,7 @@
           <a:p>
             <a:fld id="{B4C93A37-6A61-4F10-A100-9676ACB86039}" type="datetime1">
               <a:rPr lang="LID4096" smtClean="0"/>
-              <a:t>03/10/2026</a:t>
+              <a:t>03/12/2026</a:t>
             </a:fld>
             <a:endParaRPr lang="LID4096"/>
           </a:p>
@@ -2514,7 +2515,7 @@
           <a:p>
             <a:fld id="{9E73F7F9-09CC-4C21-BDB8-90E2F1A013BD}" type="datetime1">
               <a:rPr lang="LID4096" smtClean="0"/>
-              <a:t>03/10/2026</a:t>
+              <a:t>03/12/2026</a:t>
             </a:fld>
             <a:endParaRPr lang="LID4096"/>
           </a:p>
@@ -2827,7 +2828,7 @@
           <a:p>
             <a:fld id="{FD166AE6-E2E5-4774-8434-34F2AD9BDDCE}" type="datetime1">
               <a:rPr lang="LID4096" smtClean="0"/>
-              <a:t>03/10/2026</a:t>
+              <a:t>03/12/2026</a:t>
             </a:fld>
             <a:endParaRPr lang="LID4096"/>
           </a:p>
@@ -3116,7 +3117,7 @@
           <a:p>
             <a:fld id="{895E2CCE-BBFE-4BEC-9002-70F26B158681}" type="datetime1">
               <a:rPr lang="LID4096" smtClean="0"/>
-              <a:t>03/10/2026</a:t>
+              <a:t>03/12/2026</a:t>
             </a:fld>
             <a:endParaRPr lang="LID4096"/>
           </a:p>
@@ -3359,7 +3360,7 @@
           <a:p>
             <a:fld id="{C795C0FD-7BB7-48C9-86F3-9771767F1BC3}" type="datetime1">
               <a:rPr lang="LID4096" smtClean="0"/>
-              <a:t>03/10/2026</a:t>
+              <a:t>03/12/2026</a:t>
             </a:fld>
             <a:endParaRPr lang="LID4096"/>
           </a:p>
@@ -6639,8 +6640,8 @@
           </a:p>
         </p:txBody>
       </p:sp>
-      <mc:AlternateContent xmlns:mc="http://schemas.openxmlformats.org/markup-compatibility/2006">
-        <mc:Choice xmlns:a14="http://schemas.microsoft.com/office/drawing/2010/main" Requires="a14">
+      <mc:AlternateContent xmlns:mc="http://schemas.openxmlformats.org/markup-compatibility/2006" xmlns:a14="http://schemas.microsoft.com/office/drawing/2010/main">
+        <mc:Choice Requires="a14">
           <p:sp>
             <p:nvSpPr>
               <p:cNvPr id="3" name="Content Placeholder 2">
@@ -6903,7 +6904,7 @@
             </p:txBody>
           </p:sp>
         </mc:Choice>
-        <mc:Fallback>
+        <mc:Fallback xmlns="">
           <p:sp>
             <p:nvSpPr>
               <p:cNvPr id="3" name="Content Placeholder 2">
@@ -6976,8 +6977,8 @@
           </a:p>
         </p:txBody>
       </p:sp>
-      <mc:AlternateContent xmlns:mc="http://schemas.openxmlformats.org/markup-compatibility/2006">
-        <mc:Choice xmlns:a14="http://schemas.microsoft.com/office/drawing/2010/main" Requires="a14">
+      <mc:AlternateContent xmlns:mc="http://schemas.openxmlformats.org/markup-compatibility/2006" xmlns:a14="http://schemas.microsoft.com/office/drawing/2010/main">
+        <mc:Choice Requires="a14">
           <p:sp>
             <p:nvSpPr>
               <p:cNvPr id="5" name="TextBox 4">
@@ -7232,7 +7233,7 @@
             </p:txBody>
           </p:sp>
         </mc:Choice>
-        <mc:Fallback>
+        <mc:Fallback xmlns="">
           <p:sp>
             <p:nvSpPr>
               <p:cNvPr id="5" name="TextBox 4">
@@ -7282,8 +7283,8 @@
           </p:sp>
         </mc:Fallback>
       </mc:AlternateContent>
-      <mc:AlternateContent xmlns:mc="http://schemas.openxmlformats.org/markup-compatibility/2006">
-        <mc:Choice xmlns:a14="http://schemas.microsoft.com/office/drawing/2010/main" Requires="a14">
+      <mc:AlternateContent xmlns:mc="http://schemas.openxmlformats.org/markup-compatibility/2006" xmlns:a14="http://schemas.microsoft.com/office/drawing/2010/main">
+        <mc:Choice Requires="a14">
           <p:graphicFrame>
             <p:nvGraphicFramePr>
               <p:cNvPr id="6" name="Table 5">
@@ -7350,6 +7351,7 @@
                         <a:bodyPr/>
                         <a:lstStyle/>
                         <a:p>
+                          <a:pPr/>
                           <a14:m>
                             <m:oMathPara xmlns:m="http://schemas.openxmlformats.org/officeDocument/2006/math">
                               <m:oMathParaPr>
@@ -7678,7 +7680,7 @@
             </a:graphic>
           </p:graphicFrame>
         </mc:Choice>
-        <mc:Fallback>
+        <mc:Fallback xmlns="">
           <p:graphicFrame>
             <p:nvGraphicFramePr>
               <p:cNvPr id="6" name="Table 5">
@@ -8089,10 +8091,10 @@
           <p:nvPr/>
         </p:nvPicPr>
         <p:blipFill>
-          <a:blip r:embed="rId5">
+          <a:blip>
             <a:extLst>
               <a:ext uri="{96DAC541-7B7A-43D3-8B79-37D633B846F1}">
-                <asvg:svgBlip xmlns:asvg="http://schemas.microsoft.com/office/drawing/2016/SVG/main" r:embed="rId6"/>
+                <asvg:svgBlip xmlns:asvg="http://schemas.microsoft.com/office/drawing/2016/SVG/main" r:embed="rId5"/>
               </a:ext>
             </a:extLst>
           </a:blip>
@@ -8776,10 +8778,10 @@
             <p:nvPr/>
           </p:nvPicPr>
           <p:blipFill>
-            <a:blip r:embed="rId2">
+            <a:blip>
               <a:extLst>
                 <a:ext uri="{96DAC541-7B7A-43D3-8B79-37D633B846F1}">
-                  <asvg:svgBlip xmlns:asvg="http://schemas.microsoft.com/office/drawing/2016/SVG/main" r:embed="rId3"/>
+                  <asvg:svgBlip xmlns:asvg="http://schemas.microsoft.com/office/drawing/2016/SVG/main" r:embed="rId2"/>
                 </a:ext>
               </a:extLst>
             </a:blip>
@@ -10052,10 +10054,10 @@
             <p:nvPr/>
           </p:nvPicPr>
           <p:blipFill>
-            <a:blip r:embed="rId3">
+            <a:blip>
               <a:extLst>
                 <a:ext uri="{96DAC541-7B7A-43D3-8B79-37D633B846F1}">
-                  <asvg:svgBlip xmlns:asvg="http://schemas.microsoft.com/office/drawing/2016/SVG/main" r:embed="rId4"/>
+                  <asvg:svgBlip xmlns:asvg="http://schemas.microsoft.com/office/drawing/2016/SVG/main" r:embed="rId3"/>
                 </a:ext>
               </a:extLst>
             </a:blip>
@@ -15258,10 +15260,10 @@
             <p:nvPr/>
           </p:nvPicPr>
           <p:blipFill>
-            <a:blip r:embed="rId2">
+            <a:blip>
               <a:extLst>
                 <a:ext uri="{96DAC541-7B7A-43D3-8B79-37D633B846F1}">
-                  <asvg:svgBlip xmlns:asvg="http://schemas.microsoft.com/office/drawing/2016/SVG/main" r:embed="rId3"/>
+                  <asvg:svgBlip xmlns:asvg="http://schemas.microsoft.com/office/drawing/2016/SVG/main" r:embed="rId2"/>
                 </a:ext>
               </a:extLst>
             </a:blip>
@@ -19538,6 +19540,1073 @@
 <file path=ppt/slides/slide27.xml><?xml version="1.0" encoding="utf-8"?>
 <p:sld xmlns:a="http://schemas.openxmlformats.org/drawingml/2006/main" xmlns:r="http://schemas.openxmlformats.org/officeDocument/2006/relationships" xmlns:p="http://schemas.openxmlformats.org/presentationml/2006/main">
   <p:cSld>
+    <p:spTree>
+      <p:nvGrpSpPr>
+        <p:cNvPr id="1" name=""/>
+        <p:cNvGrpSpPr/>
+        <p:nvPr/>
+      </p:nvGrpSpPr>
+      <p:grpSpPr>
+        <a:xfrm>
+          <a:off x="0" y="0"/>
+          <a:ext cx="0" cy="0"/>
+          <a:chOff x="0" y="0"/>
+          <a:chExt cx="0" cy="0"/>
+        </a:xfrm>
+      </p:grpSpPr>
+      <p:sp>
+        <p:nvSpPr>
+          <p:cNvPr id="2" name="Title 1">
+            <a:extLst>
+              <a:ext uri="{FF2B5EF4-FFF2-40B4-BE49-F238E27FC236}">
+                <a16:creationId xmlns:a16="http://schemas.microsoft.com/office/drawing/2014/main" id="{03D3FA56-E009-6CB8-6AF8-A1994D6EEDCC}"/>
+              </a:ext>
+            </a:extLst>
+          </p:cNvPr>
+          <p:cNvSpPr>
+            <a:spLocks noGrp="1"/>
+          </p:cNvSpPr>
+          <p:nvPr>
+            <p:ph type="title"/>
+          </p:nvPr>
+        </p:nvSpPr>
+        <p:spPr/>
+        <p:txBody>
+          <a:bodyPr/>
+          <a:lstStyle/>
+          <a:p>
+            <a:r>
+              <a:rPr lang="en-US" dirty="0"/>
+              <a:t>Performance considerations</a:t>
+            </a:r>
+            <a:endParaRPr lang="LID4096" dirty="0"/>
+          </a:p>
+        </p:txBody>
+      </p:sp>
+      <p:sp>
+        <p:nvSpPr>
+          <p:cNvPr id="3" name="Content Placeholder 2">
+            <a:extLst>
+              <a:ext uri="{FF2B5EF4-FFF2-40B4-BE49-F238E27FC236}">
+                <a16:creationId xmlns:a16="http://schemas.microsoft.com/office/drawing/2014/main" id="{D6C827A8-40C3-53E0-F891-513A3496479A}"/>
+              </a:ext>
+            </a:extLst>
+          </p:cNvPr>
+          <p:cNvSpPr>
+            <a:spLocks noGrp="1"/>
+          </p:cNvSpPr>
+          <p:nvPr>
+            <p:ph idx="1"/>
+          </p:nvPr>
+        </p:nvSpPr>
+        <p:spPr/>
+        <p:txBody>
+          <a:bodyPr>
+            <a:normAutofit fontScale="85000" lnSpcReduction="20000"/>
+          </a:bodyPr>
+          <a:lstStyle/>
+          <a:p>
+            <a:r>
+              <a:rPr lang="en-US" dirty="0"/>
+              <a:t>Avoid warp divergence (beware of branching)!</a:t>
+            </a:r>
+          </a:p>
+          <a:p>
+            <a:r>
+              <a:rPr lang="en-US" dirty="0"/>
+              <a:t>Ensure threads have enough work</a:t>
+            </a:r>
+          </a:p>
+          <a:p>
+            <a:r>
+              <a:rPr lang="en-US" dirty="0"/>
+              <a:t>Increase arithmetic intensity</a:t>
+            </a:r>
+          </a:p>
+          <a:p>
+            <a:r>
+              <a:rPr lang="en-US" dirty="0"/>
+              <a:t>Number of threads/block </a:t>
+            </a:r>
+            <a:r>
+              <a:rPr lang="en-US" dirty="0">
+                <a:sym typeface="Symbol" panose="05050102010706020507" pitchFamily="18" charset="2"/>
+              </a:rPr>
+              <a:t></a:t>
+            </a:r>
+            <a:r>
+              <a:rPr lang="en-US" dirty="0"/>
+              <a:t> registers/shared memory</a:t>
+            </a:r>
+          </a:p>
+          <a:p>
+            <a:pPr lvl="1"/>
+            <a:r>
+              <a:rPr lang="en-US" dirty="0"/>
+              <a:t>Ensure sufficient occupancy</a:t>
+            </a:r>
+          </a:p>
+          <a:p>
+            <a:r>
+              <a:rPr lang="en-US" dirty="0"/>
+              <a:t>Exploit data locality (shared memory/L2 cache)</a:t>
+            </a:r>
+          </a:p>
+          <a:p>
+            <a:r>
+              <a:rPr lang="en-US" dirty="0"/>
+              <a:t>Minimize host-device memory transfers and synchronization</a:t>
+            </a:r>
+          </a:p>
+          <a:p>
+            <a:r>
+              <a:rPr lang="en-US" dirty="0"/>
+              <a:t>Memory access matters </a:t>
+            </a:r>
+            <a:r>
+              <a:rPr lang="en-US" dirty="0">
+                <a:sym typeface="Symbol" panose="05050102010706020507" pitchFamily="18" charset="2"/>
+              </a:rPr>
+              <a:t></a:t>
+            </a:r>
+            <a:r>
+              <a:rPr lang="en-US" dirty="0"/>
+              <a:t> data access coalescing</a:t>
+            </a:r>
+          </a:p>
+          <a:p>
+            <a:pPr lvl="1"/>
+            <a:r>
+              <a:rPr lang="en-US" dirty="0"/>
+              <a:t>Accommodate 128-byte memory transactions</a:t>
+            </a:r>
+          </a:p>
+          <a:p>
+            <a:pPr lvl="1"/>
+            <a:r>
+              <a:rPr lang="en-US" dirty="0"/>
+              <a:t>Warp should access consecutive addresses</a:t>
+            </a:r>
+            <a:br>
+              <a:rPr lang="en-US" dirty="0"/>
+            </a:br>
+            <a:r>
+              <a:rPr lang="en-US" dirty="0"/>
+              <a:t>    </a:t>
+            </a:r>
+            <a:r>
+              <a:rPr lang="en-US" dirty="0">
+                <a:sym typeface="Symbol" panose="05050102010706020507" pitchFamily="18" charset="2"/>
+              </a:rPr>
+              <a:t> </a:t>
+            </a:r>
+            <a:r>
+              <a:rPr lang="en-US" b="1" dirty="0">
+                <a:solidFill>
+                  <a:srgbClr val="C00000"/>
+                </a:solidFill>
+              </a:rPr>
+              <a:t>grid-</a:t>
+            </a:r>
+            <a:r>
+              <a:rPr lang="en-US" b="1" dirty="0" err="1">
+                <a:solidFill>
+                  <a:srgbClr val="C00000"/>
+                </a:solidFill>
+              </a:rPr>
+              <a:t>trided</a:t>
+            </a:r>
+            <a:r>
+              <a:rPr lang="en-US" b="1" dirty="0">
+                <a:solidFill>
+                  <a:srgbClr val="C00000"/>
+                </a:solidFill>
+              </a:rPr>
+              <a:t> loops</a:t>
+            </a:r>
+            <a:r>
+              <a:rPr lang="en-US" dirty="0"/>
+              <a:t> to distribute work</a:t>
+            </a:r>
+          </a:p>
+          <a:p>
+            <a:pPr lvl="1"/>
+            <a:r>
+              <a:rPr lang="en-US" dirty="0"/>
+              <a:t>Data should be aligned</a:t>
+            </a:r>
+          </a:p>
+          <a:p>
+            <a:pPr lvl="1"/>
+            <a:r>
+              <a:rPr lang="en-US" dirty="0"/>
+              <a:t>Data layout </a:t>
+            </a:r>
+            <a:r>
+              <a:rPr lang="en-US" dirty="0">
+                <a:sym typeface="Symbol" panose="05050102010706020507" pitchFamily="18" charset="2"/>
+              </a:rPr>
+              <a:t></a:t>
+            </a:r>
+            <a:r>
+              <a:rPr lang="en-US" dirty="0"/>
+              <a:t> thread access pattern (e.g., </a:t>
+            </a:r>
+            <a:r>
+              <a:rPr lang="en-US" dirty="0" err="1"/>
+              <a:t>SoA</a:t>
+            </a:r>
+            <a:r>
+              <a:rPr lang="en-US" dirty="0"/>
+              <a:t> vs. </a:t>
+            </a:r>
+            <a:r>
+              <a:rPr lang="en-US" dirty="0" err="1"/>
+              <a:t>AoS</a:t>
+            </a:r>
+            <a:r>
+              <a:rPr lang="en-US" dirty="0"/>
+              <a:t>)</a:t>
+            </a:r>
+            <a:endParaRPr lang="LID4096" dirty="0"/>
+          </a:p>
+        </p:txBody>
+      </p:sp>
+      <p:sp>
+        <p:nvSpPr>
+          <p:cNvPr id="4" name="Slide Number Placeholder 3">
+            <a:extLst>
+              <a:ext uri="{FF2B5EF4-FFF2-40B4-BE49-F238E27FC236}">
+                <a16:creationId xmlns:a16="http://schemas.microsoft.com/office/drawing/2014/main" id="{B3CEDA03-7DD6-BA46-FB39-F3E23432FABB}"/>
+              </a:ext>
+            </a:extLst>
+          </p:cNvPr>
+          <p:cNvSpPr>
+            <a:spLocks noGrp="1"/>
+          </p:cNvSpPr>
+          <p:nvPr>
+            <p:ph type="sldNum" sz="quarter" idx="12"/>
+          </p:nvPr>
+        </p:nvSpPr>
+        <p:spPr/>
+        <p:txBody>
+          <a:bodyPr/>
+          <a:lstStyle/>
+          <a:p>
+            <a:fld id="{9C7CE217-4467-4B8D-A735-B008FA7C4816}" type="slidenum">
+              <a:rPr lang="LID4096" smtClean="0"/>
+              <a:t>27</a:t>
+            </a:fld>
+            <a:endParaRPr lang="LID4096"/>
+          </a:p>
+        </p:txBody>
+      </p:sp>
+      <p:grpSp>
+        <p:nvGrpSpPr>
+          <p:cNvPr id="9" name="Group 8">
+            <a:extLst>
+              <a:ext uri="{FF2B5EF4-FFF2-40B4-BE49-F238E27FC236}">
+                <a16:creationId xmlns:a16="http://schemas.microsoft.com/office/drawing/2014/main" id="{D4BF42C1-663C-C1F1-5D36-61AA6BA95191}"/>
+              </a:ext>
+            </a:extLst>
+          </p:cNvPr>
+          <p:cNvGrpSpPr/>
+          <p:nvPr/>
+        </p:nvGrpSpPr>
+        <p:grpSpPr>
+          <a:xfrm>
+            <a:off x="6770914" y="5059688"/>
+            <a:ext cx="4379321" cy="1384995"/>
+            <a:chOff x="7532914" y="4189164"/>
+            <a:chExt cx="4379321" cy="1384995"/>
+          </a:xfrm>
+        </p:grpSpPr>
+        <p:sp>
+          <p:nvSpPr>
+            <p:cNvPr id="5" name="TextBox 4">
+              <a:extLst>
+                <a:ext uri="{FF2B5EF4-FFF2-40B4-BE49-F238E27FC236}">
+                  <a16:creationId xmlns:a16="http://schemas.microsoft.com/office/drawing/2014/main" id="{5A09B20F-7C5A-42B1-4415-C2E9C5C20FAC}"/>
+                </a:ext>
+              </a:extLst>
+            </p:cNvPr>
+            <p:cNvSpPr txBox="1"/>
+            <p:nvPr/>
+          </p:nvSpPr>
+          <p:spPr>
+            <a:xfrm>
+              <a:off x="8686800" y="4189164"/>
+              <a:ext cx="3225435" cy="1384995"/>
+            </a:xfrm>
+            <a:prstGeom prst="rect">
+              <a:avLst/>
+            </a:prstGeom>
+            <a:noFill/>
+            <a:ln>
+              <a:solidFill>
+                <a:schemeClr val="tx1"/>
+              </a:solidFill>
+            </a:ln>
+          </p:spPr>
+          <p:txBody>
+            <a:bodyPr wrap="none" rtlCol="0">
+              <a:spAutoFit/>
+            </a:bodyPr>
+            <a:lstStyle/>
+            <a:p>
+              <a:r>
+                <a:rPr lang="en-US" sz="2800" dirty="0"/>
+                <a:t>Note: opposite of</a:t>
+              </a:r>
+              <a:br>
+                <a:rPr lang="en-US" sz="2800" dirty="0"/>
+              </a:br>
+              <a:r>
+                <a:rPr lang="en-US" sz="2800" dirty="0"/>
+                <a:t>CPU multithreading</a:t>
+              </a:r>
+              <a:br>
+                <a:rPr lang="en-US" sz="2800" dirty="0"/>
+              </a:br>
+              <a:r>
+                <a:rPr lang="en-US" sz="2800" dirty="0"/>
+                <a:t>wisdom!</a:t>
+              </a:r>
+              <a:endParaRPr lang="LID4096" sz="2800" dirty="0"/>
+            </a:p>
+          </p:txBody>
+        </p:sp>
+        <p:cxnSp>
+          <p:nvCxnSpPr>
+            <p:cNvPr id="7" name="Straight Arrow Connector 6">
+              <a:extLst>
+                <a:ext uri="{FF2B5EF4-FFF2-40B4-BE49-F238E27FC236}">
+                  <a16:creationId xmlns:a16="http://schemas.microsoft.com/office/drawing/2014/main" id="{4AA095A8-D128-0A01-CEFC-39BEA7C168EB}"/>
+                </a:ext>
+              </a:extLst>
+            </p:cNvPr>
+            <p:cNvCxnSpPr>
+              <a:cxnSpLocks/>
+              <a:stCxn id="5" idx="1"/>
+            </p:cNvCxnSpPr>
+            <p:nvPr/>
+          </p:nvCxnSpPr>
+          <p:spPr>
+            <a:xfrm flipH="1" flipV="1">
+              <a:off x="7532914" y="4430486"/>
+              <a:ext cx="1153886" cy="451176"/>
+            </a:xfrm>
+            <a:prstGeom prst="straightConnector1">
+              <a:avLst/>
+            </a:prstGeom>
+            <a:ln>
+              <a:solidFill>
+                <a:schemeClr val="tx1"/>
+              </a:solidFill>
+              <a:tailEnd type="stealth" w="lg" len="lg"/>
+            </a:ln>
+          </p:spPr>
+          <p:style>
+            <a:lnRef idx="2">
+              <a:schemeClr val="accent1"/>
+            </a:lnRef>
+            <a:fillRef idx="0">
+              <a:schemeClr val="accent1"/>
+            </a:fillRef>
+            <a:effectRef idx="1">
+              <a:schemeClr val="accent1"/>
+            </a:effectRef>
+            <a:fontRef idx="minor">
+              <a:schemeClr val="tx1"/>
+            </a:fontRef>
+          </p:style>
+        </p:cxnSp>
+      </p:grpSp>
+    </p:spTree>
+    <p:extLst>
+      <p:ext uri="{BB962C8B-B14F-4D97-AF65-F5344CB8AC3E}">
+        <p14:creationId xmlns:p14="http://schemas.microsoft.com/office/powerpoint/2010/main" val="4132800206"/>
+      </p:ext>
+    </p:extLst>
+  </p:cSld>
+  <p:clrMapOvr>
+    <a:masterClrMapping/>
+  </p:clrMapOvr>
+  <p:timing>
+    <p:tnLst>
+      <p:par>
+        <p:cTn id="1" dur="indefinite" restart="never" nodeType="tmRoot">
+          <p:childTnLst>
+            <p:seq concurrent="1" nextAc="seek">
+              <p:cTn id="2" dur="indefinite" nodeType="mainSeq">
+                <p:childTnLst>
+                  <p:par>
+                    <p:cTn id="3" fill="hold">
+                      <p:stCondLst>
+                        <p:cond delay="indefinite"/>
+                        <p:cond evt="onBegin" delay="0">
+                          <p:tn val="2"/>
+                        </p:cond>
+                      </p:stCondLst>
+                      <p:childTnLst>
+                        <p:par>
+                          <p:cTn id="4" fill="hold">
+                            <p:stCondLst>
+                              <p:cond delay="0"/>
+                            </p:stCondLst>
+                            <p:childTnLst>
+                              <p:par>
+                                <p:cTn id="5" presetID="1" presetClass="entr" presetSubtype="0" fill="hold" grpId="0" nodeType="withEffect">
+                                  <p:stCondLst>
+                                    <p:cond delay="0"/>
+                                  </p:stCondLst>
+                                  <p:childTnLst>
+                                    <p:set>
+                                      <p:cBhvr>
+                                        <p:cTn id="6" dur="1" fill="hold">
+                                          <p:stCondLst>
+                                            <p:cond delay="0"/>
+                                          </p:stCondLst>
+                                        </p:cTn>
+                                        <p:tgtEl>
+                                          <p:spTgt spid="3">
+                                            <p:txEl>
+                                              <p:pRg st="0" end="0"/>
+                                            </p:txEl>
+                                          </p:spTgt>
+                                        </p:tgtEl>
+                                        <p:attrNameLst>
+                                          <p:attrName>style.visibility</p:attrName>
+                                        </p:attrNameLst>
+                                      </p:cBhvr>
+                                      <p:to>
+                                        <p:strVal val="visible"/>
+                                      </p:to>
+                                    </p:set>
+                                  </p:childTnLst>
+                                </p:cTn>
+                              </p:par>
+                            </p:childTnLst>
+                          </p:cTn>
+                        </p:par>
+                      </p:childTnLst>
+                    </p:cTn>
+                  </p:par>
+                  <p:par>
+                    <p:cTn id="7" fill="hold">
+                      <p:stCondLst>
+                        <p:cond delay="indefinite"/>
+                      </p:stCondLst>
+                      <p:childTnLst>
+                        <p:par>
+                          <p:cTn id="8" fill="hold">
+                            <p:stCondLst>
+                              <p:cond delay="0"/>
+                            </p:stCondLst>
+                            <p:childTnLst>
+                              <p:par>
+                                <p:cTn id="9" presetID="1" presetClass="entr" presetSubtype="0" fill="hold" grpId="0" nodeType="clickEffect">
+                                  <p:stCondLst>
+                                    <p:cond delay="0"/>
+                                  </p:stCondLst>
+                                  <p:childTnLst>
+                                    <p:set>
+                                      <p:cBhvr>
+                                        <p:cTn id="10" dur="1" fill="hold">
+                                          <p:stCondLst>
+                                            <p:cond delay="0"/>
+                                          </p:stCondLst>
+                                        </p:cTn>
+                                        <p:tgtEl>
+                                          <p:spTgt spid="3">
+                                            <p:txEl>
+                                              <p:pRg st="1" end="1"/>
+                                            </p:txEl>
+                                          </p:spTgt>
+                                        </p:tgtEl>
+                                        <p:attrNameLst>
+                                          <p:attrName>style.visibility</p:attrName>
+                                        </p:attrNameLst>
+                                      </p:cBhvr>
+                                      <p:to>
+                                        <p:strVal val="visible"/>
+                                      </p:to>
+                                    </p:set>
+                                  </p:childTnLst>
+                                </p:cTn>
+                              </p:par>
+                            </p:childTnLst>
+                          </p:cTn>
+                        </p:par>
+                      </p:childTnLst>
+                    </p:cTn>
+                  </p:par>
+                  <p:par>
+                    <p:cTn id="11" fill="hold">
+                      <p:stCondLst>
+                        <p:cond delay="indefinite"/>
+                      </p:stCondLst>
+                      <p:childTnLst>
+                        <p:par>
+                          <p:cTn id="12" fill="hold">
+                            <p:stCondLst>
+                              <p:cond delay="0"/>
+                            </p:stCondLst>
+                            <p:childTnLst>
+                              <p:par>
+                                <p:cTn id="13" presetID="1" presetClass="entr" presetSubtype="0" fill="hold" grpId="0" nodeType="clickEffect">
+                                  <p:stCondLst>
+                                    <p:cond delay="0"/>
+                                  </p:stCondLst>
+                                  <p:childTnLst>
+                                    <p:set>
+                                      <p:cBhvr>
+                                        <p:cTn id="14" dur="1" fill="hold">
+                                          <p:stCondLst>
+                                            <p:cond delay="0"/>
+                                          </p:stCondLst>
+                                        </p:cTn>
+                                        <p:tgtEl>
+                                          <p:spTgt spid="3">
+                                            <p:txEl>
+                                              <p:pRg st="2" end="2"/>
+                                            </p:txEl>
+                                          </p:spTgt>
+                                        </p:tgtEl>
+                                        <p:attrNameLst>
+                                          <p:attrName>style.visibility</p:attrName>
+                                        </p:attrNameLst>
+                                      </p:cBhvr>
+                                      <p:to>
+                                        <p:strVal val="visible"/>
+                                      </p:to>
+                                    </p:set>
+                                  </p:childTnLst>
+                                </p:cTn>
+                              </p:par>
+                            </p:childTnLst>
+                          </p:cTn>
+                        </p:par>
+                      </p:childTnLst>
+                    </p:cTn>
+                  </p:par>
+                  <p:par>
+                    <p:cTn id="15" fill="hold">
+                      <p:stCondLst>
+                        <p:cond delay="indefinite"/>
+                      </p:stCondLst>
+                      <p:childTnLst>
+                        <p:par>
+                          <p:cTn id="16" fill="hold">
+                            <p:stCondLst>
+                              <p:cond delay="0"/>
+                            </p:stCondLst>
+                            <p:childTnLst>
+                              <p:par>
+                                <p:cTn id="17" presetID="1" presetClass="entr" presetSubtype="0" fill="hold" grpId="0" nodeType="clickEffect">
+                                  <p:stCondLst>
+                                    <p:cond delay="0"/>
+                                  </p:stCondLst>
+                                  <p:childTnLst>
+                                    <p:set>
+                                      <p:cBhvr>
+                                        <p:cTn id="18" dur="1" fill="hold">
+                                          <p:stCondLst>
+                                            <p:cond delay="0"/>
+                                          </p:stCondLst>
+                                        </p:cTn>
+                                        <p:tgtEl>
+                                          <p:spTgt spid="3">
+                                            <p:txEl>
+                                              <p:pRg st="3" end="3"/>
+                                            </p:txEl>
+                                          </p:spTgt>
+                                        </p:tgtEl>
+                                        <p:attrNameLst>
+                                          <p:attrName>style.visibility</p:attrName>
+                                        </p:attrNameLst>
+                                      </p:cBhvr>
+                                      <p:to>
+                                        <p:strVal val="visible"/>
+                                      </p:to>
+                                    </p:set>
+                                  </p:childTnLst>
+                                </p:cTn>
+                              </p:par>
+                            </p:childTnLst>
+                          </p:cTn>
+                        </p:par>
+                      </p:childTnLst>
+                    </p:cTn>
+                  </p:par>
+                  <p:par>
+                    <p:cTn id="19" fill="hold">
+                      <p:stCondLst>
+                        <p:cond delay="indefinite"/>
+                      </p:stCondLst>
+                      <p:childTnLst>
+                        <p:par>
+                          <p:cTn id="20" fill="hold">
+                            <p:stCondLst>
+                              <p:cond delay="0"/>
+                            </p:stCondLst>
+                            <p:childTnLst>
+                              <p:par>
+                                <p:cTn id="21" presetID="1" presetClass="entr" presetSubtype="0" fill="hold" grpId="0" nodeType="clickEffect">
+                                  <p:stCondLst>
+                                    <p:cond delay="0"/>
+                                  </p:stCondLst>
+                                  <p:childTnLst>
+                                    <p:set>
+                                      <p:cBhvr>
+                                        <p:cTn id="22" dur="1" fill="hold">
+                                          <p:stCondLst>
+                                            <p:cond delay="0"/>
+                                          </p:stCondLst>
+                                        </p:cTn>
+                                        <p:tgtEl>
+                                          <p:spTgt spid="3">
+                                            <p:txEl>
+                                              <p:pRg st="4" end="4"/>
+                                            </p:txEl>
+                                          </p:spTgt>
+                                        </p:tgtEl>
+                                        <p:attrNameLst>
+                                          <p:attrName>style.visibility</p:attrName>
+                                        </p:attrNameLst>
+                                      </p:cBhvr>
+                                      <p:to>
+                                        <p:strVal val="visible"/>
+                                      </p:to>
+                                    </p:set>
+                                  </p:childTnLst>
+                                </p:cTn>
+                              </p:par>
+                            </p:childTnLst>
+                          </p:cTn>
+                        </p:par>
+                      </p:childTnLst>
+                    </p:cTn>
+                  </p:par>
+                  <p:par>
+                    <p:cTn id="23" fill="hold">
+                      <p:stCondLst>
+                        <p:cond delay="indefinite"/>
+                      </p:stCondLst>
+                      <p:childTnLst>
+                        <p:par>
+                          <p:cTn id="24" fill="hold">
+                            <p:stCondLst>
+                              <p:cond delay="0"/>
+                            </p:stCondLst>
+                            <p:childTnLst>
+                              <p:par>
+                                <p:cTn id="25" presetID="1" presetClass="entr" presetSubtype="0" fill="hold" grpId="0" nodeType="clickEffect">
+                                  <p:stCondLst>
+                                    <p:cond delay="0"/>
+                                  </p:stCondLst>
+                                  <p:childTnLst>
+                                    <p:set>
+                                      <p:cBhvr>
+                                        <p:cTn id="26" dur="1" fill="hold">
+                                          <p:stCondLst>
+                                            <p:cond delay="0"/>
+                                          </p:stCondLst>
+                                        </p:cTn>
+                                        <p:tgtEl>
+                                          <p:spTgt spid="3">
+                                            <p:txEl>
+                                              <p:pRg st="5" end="5"/>
+                                            </p:txEl>
+                                          </p:spTgt>
+                                        </p:tgtEl>
+                                        <p:attrNameLst>
+                                          <p:attrName>style.visibility</p:attrName>
+                                        </p:attrNameLst>
+                                      </p:cBhvr>
+                                      <p:to>
+                                        <p:strVal val="visible"/>
+                                      </p:to>
+                                    </p:set>
+                                  </p:childTnLst>
+                                </p:cTn>
+                              </p:par>
+                            </p:childTnLst>
+                          </p:cTn>
+                        </p:par>
+                      </p:childTnLst>
+                    </p:cTn>
+                  </p:par>
+                  <p:par>
+                    <p:cTn id="27" fill="hold">
+                      <p:stCondLst>
+                        <p:cond delay="indefinite"/>
+                      </p:stCondLst>
+                      <p:childTnLst>
+                        <p:par>
+                          <p:cTn id="28" fill="hold">
+                            <p:stCondLst>
+                              <p:cond delay="0"/>
+                            </p:stCondLst>
+                            <p:childTnLst>
+                              <p:par>
+                                <p:cTn id="29" presetID="1" presetClass="entr" presetSubtype="0" fill="hold" grpId="0" nodeType="clickEffect">
+                                  <p:stCondLst>
+                                    <p:cond delay="0"/>
+                                  </p:stCondLst>
+                                  <p:childTnLst>
+                                    <p:set>
+                                      <p:cBhvr>
+                                        <p:cTn id="30" dur="1" fill="hold">
+                                          <p:stCondLst>
+                                            <p:cond delay="0"/>
+                                          </p:stCondLst>
+                                        </p:cTn>
+                                        <p:tgtEl>
+                                          <p:spTgt spid="3">
+                                            <p:txEl>
+                                              <p:pRg st="6" end="6"/>
+                                            </p:txEl>
+                                          </p:spTgt>
+                                        </p:tgtEl>
+                                        <p:attrNameLst>
+                                          <p:attrName>style.visibility</p:attrName>
+                                        </p:attrNameLst>
+                                      </p:cBhvr>
+                                      <p:to>
+                                        <p:strVal val="visible"/>
+                                      </p:to>
+                                    </p:set>
+                                  </p:childTnLst>
+                                </p:cTn>
+                              </p:par>
+                            </p:childTnLst>
+                          </p:cTn>
+                        </p:par>
+                      </p:childTnLst>
+                    </p:cTn>
+                  </p:par>
+                  <p:par>
+                    <p:cTn id="31" fill="hold">
+                      <p:stCondLst>
+                        <p:cond delay="indefinite"/>
+                      </p:stCondLst>
+                      <p:childTnLst>
+                        <p:par>
+                          <p:cTn id="32" fill="hold">
+                            <p:stCondLst>
+                              <p:cond delay="0"/>
+                            </p:stCondLst>
+                            <p:childTnLst>
+                              <p:par>
+                                <p:cTn id="33" presetID="1" presetClass="entr" presetSubtype="0" fill="hold" grpId="0" nodeType="clickEffect">
+                                  <p:stCondLst>
+                                    <p:cond delay="0"/>
+                                  </p:stCondLst>
+                                  <p:childTnLst>
+                                    <p:set>
+                                      <p:cBhvr>
+                                        <p:cTn id="34" dur="1" fill="hold">
+                                          <p:stCondLst>
+                                            <p:cond delay="0"/>
+                                          </p:stCondLst>
+                                        </p:cTn>
+                                        <p:tgtEl>
+                                          <p:spTgt spid="3">
+                                            <p:txEl>
+                                              <p:pRg st="7" end="7"/>
+                                            </p:txEl>
+                                          </p:spTgt>
+                                        </p:tgtEl>
+                                        <p:attrNameLst>
+                                          <p:attrName>style.visibility</p:attrName>
+                                        </p:attrNameLst>
+                                      </p:cBhvr>
+                                      <p:to>
+                                        <p:strVal val="visible"/>
+                                      </p:to>
+                                    </p:set>
+                                  </p:childTnLst>
+                                </p:cTn>
+                              </p:par>
+                            </p:childTnLst>
+                          </p:cTn>
+                        </p:par>
+                      </p:childTnLst>
+                    </p:cTn>
+                  </p:par>
+                  <p:par>
+                    <p:cTn id="35" fill="hold">
+                      <p:stCondLst>
+                        <p:cond delay="indefinite"/>
+                      </p:stCondLst>
+                      <p:childTnLst>
+                        <p:par>
+                          <p:cTn id="36" fill="hold">
+                            <p:stCondLst>
+                              <p:cond delay="0"/>
+                            </p:stCondLst>
+                            <p:childTnLst>
+                              <p:par>
+                                <p:cTn id="37" presetID="1" presetClass="entr" presetSubtype="0" fill="hold" grpId="0" nodeType="clickEffect">
+                                  <p:stCondLst>
+                                    <p:cond delay="0"/>
+                                  </p:stCondLst>
+                                  <p:childTnLst>
+                                    <p:set>
+                                      <p:cBhvr>
+                                        <p:cTn id="38" dur="1" fill="hold">
+                                          <p:stCondLst>
+                                            <p:cond delay="0"/>
+                                          </p:stCondLst>
+                                        </p:cTn>
+                                        <p:tgtEl>
+                                          <p:spTgt spid="3">
+                                            <p:txEl>
+                                              <p:pRg st="8" end="8"/>
+                                            </p:txEl>
+                                          </p:spTgt>
+                                        </p:tgtEl>
+                                        <p:attrNameLst>
+                                          <p:attrName>style.visibility</p:attrName>
+                                        </p:attrNameLst>
+                                      </p:cBhvr>
+                                      <p:to>
+                                        <p:strVal val="visible"/>
+                                      </p:to>
+                                    </p:set>
+                                  </p:childTnLst>
+                                </p:cTn>
+                              </p:par>
+                            </p:childTnLst>
+                          </p:cTn>
+                        </p:par>
+                      </p:childTnLst>
+                    </p:cTn>
+                  </p:par>
+                  <p:par>
+                    <p:cTn id="39" fill="hold">
+                      <p:stCondLst>
+                        <p:cond delay="indefinite"/>
+                      </p:stCondLst>
+                      <p:childTnLst>
+                        <p:par>
+                          <p:cTn id="40" fill="hold">
+                            <p:stCondLst>
+                              <p:cond delay="0"/>
+                            </p:stCondLst>
+                            <p:childTnLst>
+                              <p:par>
+                                <p:cTn id="41" presetID="1" presetClass="entr" presetSubtype="0" fill="hold" grpId="0" nodeType="clickEffect">
+                                  <p:stCondLst>
+                                    <p:cond delay="0"/>
+                                  </p:stCondLst>
+                                  <p:childTnLst>
+                                    <p:set>
+                                      <p:cBhvr>
+                                        <p:cTn id="42" dur="1" fill="hold">
+                                          <p:stCondLst>
+                                            <p:cond delay="0"/>
+                                          </p:stCondLst>
+                                        </p:cTn>
+                                        <p:tgtEl>
+                                          <p:spTgt spid="3">
+                                            <p:txEl>
+                                              <p:pRg st="9" end="9"/>
+                                            </p:txEl>
+                                          </p:spTgt>
+                                        </p:tgtEl>
+                                        <p:attrNameLst>
+                                          <p:attrName>style.visibility</p:attrName>
+                                        </p:attrNameLst>
+                                      </p:cBhvr>
+                                      <p:to>
+                                        <p:strVal val="visible"/>
+                                      </p:to>
+                                    </p:set>
+                                  </p:childTnLst>
+                                </p:cTn>
+                              </p:par>
+                            </p:childTnLst>
+                          </p:cTn>
+                        </p:par>
+                      </p:childTnLst>
+                    </p:cTn>
+                  </p:par>
+                  <p:par>
+                    <p:cTn id="43" fill="hold">
+                      <p:stCondLst>
+                        <p:cond delay="indefinite"/>
+                      </p:stCondLst>
+                      <p:childTnLst>
+                        <p:par>
+                          <p:cTn id="44" fill="hold">
+                            <p:stCondLst>
+                              <p:cond delay="0"/>
+                            </p:stCondLst>
+                            <p:childTnLst>
+                              <p:par>
+                                <p:cTn id="45" presetID="1" presetClass="entr" presetSubtype="0" fill="hold" nodeType="clickEffect">
+                                  <p:stCondLst>
+                                    <p:cond delay="0"/>
+                                  </p:stCondLst>
+                                  <p:childTnLst>
+                                    <p:set>
+                                      <p:cBhvr>
+                                        <p:cTn id="46" dur="1" fill="hold">
+                                          <p:stCondLst>
+                                            <p:cond delay="0"/>
+                                          </p:stCondLst>
+                                        </p:cTn>
+                                        <p:tgtEl>
+                                          <p:spTgt spid="9"/>
+                                        </p:tgtEl>
+                                        <p:attrNameLst>
+                                          <p:attrName>style.visibility</p:attrName>
+                                        </p:attrNameLst>
+                                      </p:cBhvr>
+                                      <p:to>
+                                        <p:strVal val="visible"/>
+                                      </p:to>
+                                    </p:set>
+                                  </p:childTnLst>
+                                </p:cTn>
+                              </p:par>
+                            </p:childTnLst>
+                          </p:cTn>
+                        </p:par>
+                      </p:childTnLst>
+                    </p:cTn>
+                  </p:par>
+                  <p:par>
+                    <p:cTn id="47" fill="hold">
+                      <p:stCondLst>
+                        <p:cond delay="indefinite"/>
+                      </p:stCondLst>
+                      <p:childTnLst>
+                        <p:par>
+                          <p:cTn id="48" fill="hold">
+                            <p:stCondLst>
+                              <p:cond delay="0"/>
+                            </p:stCondLst>
+                            <p:childTnLst>
+                              <p:par>
+                                <p:cTn id="49" presetID="1" presetClass="entr" presetSubtype="0" fill="hold" grpId="0" nodeType="clickEffect">
+                                  <p:stCondLst>
+                                    <p:cond delay="0"/>
+                                  </p:stCondLst>
+                                  <p:childTnLst>
+                                    <p:set>
+                                      <p:cBhvr>
+                                        <p:cTn id="50" dur="1" fill="hold">
+                                          <p:stCondLst>
+                                            <p:cond delay="0"/>
+                                          </p:stCondLst>
+                                        </p:cTn>
+                                        <p:tgtEl>
+                                          <p:spTgt spid="3">
+                                            <p:txEl>
+                                              <p:pRg st="10" end="10"/>
+                                            </p:txEl>
+                                          </p:spTgt>
+                                        </p:tgtEl>
+                                        <p:attrNameLst>
+                                          <p:attrName>style.visibility</p:attrName>
+                                        </p:attrNameLst>
+                                      </p:cBhvr>
+                                      <p:to>
+                                        <p:strVal val="visible"/>
+                                      </p:to>
+                                    </p:set>
+                                  </p:childTnLst>
+                                </p:cTn>
+                              </p:par>
+                            </p:childTnLst>
+                          </p:cTn>
+                        </p:par>
+                      </p:childTnLst>
+                    </p:cTn>
+                  </p:par>
+                  <p:par>
+                    <p:cTn id="51" fill="hold">
+                      <p:stCondLst>
+                        <p:cond delay="indefinite"/>
+                      </p:stCondLst>
+                      <p:childTnLst>
+                        <p:par>
+                          <p:cTn id="52" fill="hold">
+                            <p:stCondLst>
+                              <p:cond delay="0"/>
+                            </p:stCondLst>
+                            <p:childTnLst>
+                              <p:par>
+                                <p:cTn id="53" presetID="1" presetClass="entr" presetSubtype="0" fill="hold" grpId="0" nodeType="clickEffect">
+                                  <p:stCondLst>
+                                    <p:cond delay="0"/>
+                                  </p:stCondLst>
+                                  <p:childTnLst>
+                                    <p:set>
+                                      <p:cBhvr>
+                                        <p:cTn id="54" dur="1" fill="hold">
+                                          <p:stCondLst>
+                                            <p:cond delay="0"/>
+                                          </p:stCondLst>
+                                        </p:cTn>
+                                        <p:tgtEl>
+                                          <p:spTgt spid="3">
+                                            <p:txEl>
+                                              <p:pRg st="11" end="11"/>
+                                            </p:txEl>
+                                          </p:spTgt>
+                                        </p:tgtEl>
+                                        <p:attrNameLst>
+                                          <p:attrName>style.visibility</p:attrName>
+                                        </p:attrNameLst>
+                                      </p:cBhvr>
+                                      <p:to>
+                                        <p:strVal val="visible"/>
+                                      </p:to>
+                                    </p:set>
+                                  </p:childTnLst>
+                                </p:cTn>
+                              </p:par>
+                            </p:childTnLst>
+                          </p:cTn>
+                        </p:par>
+                      </p:childTnLst>
+                    </p:cTn>
+                  </p:par>
+                </p:childTnLst>
+              </p:cTn>
+              <p:prevCondLst>
+                <p:cond evt="onPrev" delay="0">
+                  <p:tgtEl>
+                    <p:sldTgt/>
+                  </p:tgtEl>
+                </p:cond>
+              </p:prevCondLst>
+              <p:nextCondLst>
+                <p:cond evt="onNext" delay="0">
+                  <p:tgtEl>
+                    <p:sldTgt/>
+                  </p:tgtEl>
+                </p:cond>
+              </p:nextCondLst>
+            </p:seq>
+          </p:childTnLst>
+        </p:cTn>
+      </p:par>
+    </p:tnLst>
+    <p:bldLst>
+      <p:bldP spid="3" grpId="0" uiExpand="1" build="p" bldLvl="2"/>
+    </p:bldLst>
+  </p:timing>
+</p:sld>
+</file>
+
+<file path=ppt/slides/slide28.xml><?xml version="1.0" encoding="utf-8"?>
+<p:sld xmlns:a="http://schemas.openxmlformats.org/drawingml/2006/main" xmlns:r="http://schemas.openxmlformats.org/officeDocument/2006/relationships" xmlns:p="http://schemas.openxmlformats.org/presentationml/2006/main">
+  <p:cSld>
     <p:bg>
       <p:bgPr>
         <a:solidFill>
@@ -19780,7 +20849,7 @@
                 </a:spcAft>
                 <a:defRPr/>
               </a:pPr>
-              <a:t>27</a:t>
+              <a:t>28</a:t>
             </a:fld>
             <a:endParaRPr lang="en-US">
               <a:solidFill>
@@ -19804,7 +20873,7 @@
 </p:sld>
 </file>
 
-<file path=ppt/slides/slide28.xml><?xml version="1.0" encoding="utf-8"?>
+<file path=ppt/slides/slide29.xml><?xml version="1.0" encoding="utf-8"?>
 <p:sld xmlns:a="http://schemas.openxmlformats.org/drawingml/2006/main" xmlns:r="http://schemas.openxmlformats.org/officeDocument/2006/relationships" xmlns:p="http://schemas.openxmlformats.org/presentationml/2006/main">
   <p:cSld>
     <p:spTree>
@@ -20592,7 +21661,7 @@
           <a:p>
             <a:fld id="{9C7CE217-4467-4B8D-A735-B008FA7C4816}" type="slidenum">
               <a:rPr lang="LID4096" smtClean="0"/>
-              <a:t>28</a:t>
+              <a:t>29</a:t>
             </a:fld>
             <a:endParaRPr lang="LID4096"/>
           </a:p>
@@ -20611,7 +21680,102 @@
 </p:sld>
 </file>
 
-<file path=ppt/slides/slide29.xml><?xml version="1.0" encoding="utf-8"?>
+<file path=ppt/slides/slide3.xml><?xml version="1.0" encoding="utf-8"?>
+<p:sld xmlns:a="http://schemas.openxmlformats.org/drawingml/2006/main" xmlns:r="http://schemas.openxmlformats.org/officeDocument/2006/relationships" xmlns:p="http://schemas.openxmlformats.org/presentationml/2006/main">
+  <p:cSld>
+    <p:spTree>
+      <p:nvGrpSpPr>
+        <p:cNvPr id="1" name=""/>
+        <p:cNvGrpSpPr/>
+        <p:nvPr/>
+      </p:nvGrpSpPr>
+      <p:grpSpPr>
+        <a:xfrm>
+          <a:off x="0" y="0"/>
+          <a:ext cx="0" cy="0"/>
+          <a:chOff x="0" y="0"/>
+          <a:chExt cx="0" cy="0"/>
+        </a:xfrm>
+      </p:grpSpPr>
+      <p:pic>
+        <p:nvPicPr>
+          <p:cNvPr id="3" name="Picture 2" descr="Qr code&#10;&#10;Description automatically generated">
+            <a:extLst>
+              <a:ext uri="{FF2B5EF4-FFF2-40B4-BE49-F238E27FC236}">
+                <a16:creationId xmlns:a16="http://schemas.microsoft.com/office/drawing/2014/main" id="{73A4FCC5-DC3D-4500-9780-EECF84D9A9C9}"/>
+              </a:ext>
+            </a:extLst>
+          </p:cNvPr>
+          <p:cNvPicPr>
+            <a:picLocks noChangeAspect="1"/>
+          </p:cNvPicPr>
+          <p:nvPr/>
+        </p:nvPicPr>
+        <p:blipFill>
+          <a:blip r:embed="rId2">
+            <a:extLst>
+              <a:ext uri="{28A0092B-C50C-407E-A947-70E740481C1C}">
+                <a14:useLocalDpi xmlns:a14="http://schemas.microsoft.com/office/drawing/2010/main" val="0"/>
+              </a:ext>
+            </a:extLst>
+          </a:blip>
+          <a:stretch>
+            <a:fillRect/>
+          </a:stretch>
+        </p:blipFill>
+        <p:spPr>
+          <a:xfrm>
+            <a:off x="0" y="0"/>
+            <a:ext cx="12192000" cy="6858000"/>
+          </a:xfrm>
+          <a:prstGeom prst="rect">
+            <a:avLst/>
+          </a:prstGeom>
+        </p:spPr>
+      </p:pic>
+      <p:sp>
+        <p:nvSpPr>
+          <p:cNvPr id="2" name="Slide Number Placeholder 1">
+            <a:extLst>
+              <a:ext uri="{FF2B5EF4-FFF2-40B4-BE49-F238E27FC236}">
+                <a16:creationId xmlns:a16="http://schemas.microsoft.com/office/drawing/2014/main" id="{F570AEBC-58DC-06FC-AE67-813A2E7C9CA8}"/>
+              </a:ext>
+            </a:extLst>
+          </p:cNvPr>
+          <p:cNvSpPr>
+            <a:spLocks noGrp="1"/>
+          </p:cNvSpPr>
+          <p:nvPr>
+            <p:ph type="sldNum" sz="quarter" idx="12"/>
+          </p:nvPr>
+        </p:nvSpPr>
+        <p:spPr/>
+        <p:txBody>
+          <a:bodyPr/>
+          <a:lstStyle/>
+          <a:p>
+            <a:fld id="{9C7CE217-4467-4B8D-A735-B008FA7C4816}" type="slidenum">
+              <a:rPr lang="LID4096" smtClean="0"/>
+              <a:t>3</a:t>
+            </a:fld>
+            <a:endParaRPr lang="LID4096"/>
+          </a:p>
+        </p:txBody>
+      </p:sp>
+    </p:spTree>
+    <p:extLst>
+      <p:ext uri="{BB962C8B-B14F-4D97-AF65-F5344CB8AC3E}">
+        <p14:creationId xmlns:p14="http://schemas.microsoft.com/office/powerpoint/2010/main" val="2488509471"/>
+      </p:ext>
+    </p:extLst>
+  </p:cSld>
+  <p:clrMapOvr>
+    <a:masterClrMapping/>
+  </p:clrMapOvr>
+</p:sld>
+</file>
+
+<file path=ppt/slides/slide30.xml><?xml version="1.0" encoding="utf-8"?>
 <p:sld xmlns:a="http://schemas.openxmlformats.org/drawingml/2006/main" xmlns:r="http://schemas.openxmlformats.org/officeDocument/2006/relationships" xmlns:p="http://schemas.openxmlformats.org/presentationml/2006/main">
   <p:cSld>
     <p:spTree>
@@ -21535,7 +22699,7 @@
           <a:p>
             <a:fld id="{9C7CE217-4467-4B8D-A735-B008FA7C4816}" type="slidenum">
               <a:rPr lang="LID4096" smtClean="0"/>
-              <a:t>29</a:t>
+              <a:t>30</a:t>
             </a:fld>
             <a:endParaRPr lang="LID4096"/>
           </a:p>
@@ -21738,102 +22902,7 @@
 </p:sld>
 </file>
 
-<file path=ppt/slides/slide3.xml><?xml version="1.0" encoding="utf-8"?>
-<p:sld xmlns:a="http://schemas.openxmlformats.org/drawingml/2006/main" xmlns:r="http://schemas.openxmlformats.org/officeDocument/2006/relationships" xmlns:p="http://schemas.openxmlformats.org/presentationml/2006/main">
-  <p:cSld>
-    <p:spTree>
-      <p:nvGrpSpPr>
-        <p:cNvPr id="1" name=""/>
-        <p:cNvGrpSpPr/>
-        <p:nvPr/>
-      </p:nvGrpSpPr>
-      <p:grpSpPr>
-        <a:xfrm>
-          <a:off x="0" y="0"/>
-          <a:ext cx="0" cy="0"/>
-          <a:chOff x="0" y="0"/>
-          <a:chExt cx="0" cy="0"/>
-        </a:xfrm>
-      </p:grpSpPr>
-      <p:pic>
-        <p:nvPicPr>
-          <p:cNvPr id="3" name="Picture 2" descr="Qr code&#10;&#10;Description automatically generated">
-            <a:extLst>
-              <a:ext uri="{FF2B5EF4-FFF2-40B4-BE49-F238E27FC236}">
-                <a16:creationId xmlns:a16="http://schemas.microsoft.com/office/drawing/2014/main" id="{73A4FCC5-DC3D-4500-9780-EECF84D9A9C9}"/>
-              </a:ext>
-            </a:extLst>
-          </p:cNvPr>
-          <p:cNvPicPr>
-            <a:picLocks noChangeAspect="1"/>
-          </p:cNvPicPr>
-          <p:nvPr/>
-        </p:nvPicPr>
-        <p:blipFill>
-          <a:blip r:embed="rId2">
-            <a:extLst>
-              <a:ext uri="{28A0092B-C50C-407E-A947-70E740481C1C}">
-                <a14:useLocalDpi xmlns:a14="http://schemas.microsoft.com/office/drawing/2010/main" val="0"/>
-              </a:ext>
-            </a:extLst>
-          </a:blip>
-          <a:stretch>
-            <a:fillRect/>
-          </a:stretch>
-        </p:blipFill>
-        <p:spPr>
-          <a:xfrm>
-            <a:off x="0" y="0"/>
-            <a:ext cx="12192000" cy="6858000"/>
-          </a:xfrm>
-          <a:prstGeom prst="rect">
-            <a:avLst/>
-          </a:prstGeom>
-        </p:spPr>
-      </p:pic>
-      <p:sp>
-        <p:nvSpPr>
-          <p:cNvPr id="2" name="Slide Number Placeholder 1">
-            <a:extLst>
-              <a:ext uri="{FF2B5EF4-FFF2-40B4-BE49-F238E27FC236}">
-                <a16:creationId xmlns:a16="http://schemas.microsoft.com/office/drawing/2014/main" id="{F570AEBC-58DC-06FC-AE67-813A2E7C9CA8}"/>
-              </a:ext>
-            </a:extLst>
-          </p:cNvPr>
-          <p:cNvSpPr>
-            <a:spLocks noGrp="1"/>
-          </p:cNvSpPr>
-          <p:nvPr>
-            <p:ph type="sldNum" sz="quarter" idx="12"/>
-          </p:nvPr>
-        </p:nvSpPr>
-        <p:spPr/>
-        <p:txBody>
-          <a:bodyPr/>
-          <a:lstStyle/>
-          <a:p>
-            <a:fld id="{9C7CE217-4467-4B8D-A735-B008FA7C4816}" type="slidenum">
-              <a:rPr lang="LID4096" smtClean="0"/>
-              <a:t>3</a:t>
-            </a:fld>
-            <a:endParaRPr lang="LID4096"/>
-          </a:p>
-        </p:txBody>
-      </p:sp>
-    </p:spTree>
-    <p:extLst>
-      <p:ext uri="{BB962C8B-B14F-4D97-AF65-F5344CB8AC3E}">
-        <p14:creationId xmlns:p14="http://schemas.microsoft.com/office/powerpoint/2010/main" val="2488509471"/>
-      </p:ext>
-    </p:extLst>
-  </p:cSld>
-  <p:clrMapOvr>
-    <a:masterClrMapping/>
-  </p:clrMapOvr>
-</p:sld>
-</file>
-
-<file path=ppt/slides/slide30.xml><?xml version="1.0" encoding="utf-8"?>
+<file path=ppt/slides/slide31.xml><?xml version="1.0" encoding="utf-8"?>
 <p:sld xmlns:a="http://schemas.openxmlformats.org/drawingml/2006/main" xmlns:r="http://schemas.openxmlformats.org/officeDocument/2006/relationships" xmlns:p="http://schemas.openxmlformats.org/presentationml/2006/main">
   <p:cSld>
     <p:spTree>
@@ -22656,7 +23725,7 @@
           <a:p>
             <a:fld id="{9C7CE217-4467-4B8D-A735-B008FA7C4816}" type="slidenum">
               <a:rPr lang="LID4096" smtClean="0"/>
-              <a:t>30</a:t>
+              <a:t>31</a:t>
             </a:fld>
             <a:endParaRPr lang="LID4096"/>
           </a:p>
@@ -23089,7 +24158,7 @@
 </p:sld>
 </file>
 
-<file path=ppt/slides/slide31.xml><?xml version="1.0" encoding="utf-8"?>
+<file path=ppt/slides/slide32.xml><?xml version="1.0" encoding="utf-8"?>
 <p:sld xmlns:a="http://schemas.openxmlformats.org/drawingml/2006/main" xmlns:r="http://schemas.openxmlformats.org/officeDocument/2006/relationships" xmlns:p="http://schemas.openxmlformats.org/presentationml/2006/main">
   <p:cSld>
     <p:spTree>
@@ -23605,7 +24674,7 @@
           <a:p>
             <a:fld id="{9C7CE217-4467-4B8D-A735-B008FA7C4816}" type="slidenum">
               <a:rPr lang="LID4096" smtClean="0"/>
-              <a:t>31</a:t>
+              <a:t>32</a:t>
             </a:fld>
             <a:endParaRPr lang="LID4096"/>
           </a:p>
@@ -23624,7 +24693,7 @@
 </p:sld>
 </file>
 
-<file path=ppt/slides/slide32.xml><?xml version="1.0" encoding="utf-8"?>
+<file path=ppt/slides/slide33.xml><?xml version="1.0" encoding="utf-8"?>
 <p:sld xmlns:a="http://schemas.openxmlformats.org/drawingml/2006/main" xmlns:r="http://schemas.openxmlformats.org/officeDocument/2006/relationships" xmlns:p="http://schemas.openxmlformats.org/presentationml/2006/main">
   <p:cSld>
     <p:spTree>
@@ -23786,7 +24855,7 @@
           <a:p>
             <a:fld id="{9C7CE217-4467-4B8D-A735-B008FA7C4816}" type="slidenum">
               <a:rPr lang="LID4096" smtClean="0"/>
-              <a:t>32</a:t>
+              <a:t>33</a:t>
             </a:fld>
             <a:endParaRPr lang="LID4096"/>
           </a:p>
@@ -25837,10 +26906,10 @@
           <p:nvPr/>
         </p:nvPicPr>
         <p:blipFill>
-          <a:blip r:embed="rId4">
+          <a:blip>
             <a:extLst>
               <a:ext uri="{96DAC541-7B7A-43D3-8B79-37D633B846F1}">
-                <asvg:svgBlip xmlns:asvg="http://schemas.microsoft.com/office/drawing/2016/SVG/main" r:embed="rId5"/>
+                <asvg:svgBlip xmlns:asvg="http://schemas.microsoft.com/office/drawing/2016/SVG/main" r:embed="rId4"/>
               </a:ext>
             </a:extLst>
           </a:blip>
@@ -25873,10 +26942,10 @@
           <p:nvPr/>
         </p:nvPicPr>
         <p:blipFill>
-          <a:blip r:embed="rId6">
+          <a:blip>
             <a:extLst>
               <a:ext uri="{96DAC541-7B7A-43D3-8B79-37D633B846F1}">
-                <asvg:svgBlip xmlns:asvg="http://schemas.microsoft.com/office/drawing/2016/SVG/main" r:embed="rId7"/>
+                <asvg:svgBlip xmlns:asvg="http://schemas.microsoft.com/office/drawing/2016/SVG/main" r:embed="rId5"/>
               </a:ext>
             </a:extLst>
           </a:blip>
@@ -25909,10 +26978,10 @@
           <p:nvPr/>
         </p:nvPicPr>
         <p:blipFill>
-          <a:blip r:embed="rId8">
+          <a:blip>
             <a:extLst>
               <a:ext uri="{96DAC541-7B7A-43D3-8B79-37D633B846F1}">
-                <asvg:svgBlip xmlns:asvg="http://schemas.microsoft.com/office/drawing/2016/SVG/main" r:embed="rId9"/>
+                <asvg:svgBlip xmlns:asvg="http://schemas.microsoft.com/office/drawing/2016/SVG/main" r:embed="rId6"/>
               </a:ext>
             </a:extLst>
           </a:blip>
@@ -25945,10 +27014,10 @@
           <p:nvPr/>
         </p:nvPicPr>
         <p:blipFill>
-          <a:blip r:embed="rId10">
+          <a:blip>
             <a:extLst>
               <a:ext uri="{96DAC541-7B7A-43D3-8B79-37D633B846F1}">
-                <asvg:svgBlip xmlns:asvg="http://schemas.microsoft.com/office/drawing/2016/SVG/main" r:embed="rId11"/>
+                <asvg:svgBlip xmlns:asvg="http://schemas.microsoft.com/office/drawing/2016/SVG/main" r:embed="rId7"/>
               </a:ext>
             </a:extLst>
           </a:blip>

</xml_diff>